<commit_message>
chore: rebuild presentation deck from updated script
</commit_message>
<xml_diff>
--- a/presentation.pptx
+++ b/presentation.pptx
@@ -27463,7 +27463,7 @@
         <p:spPr>
           <a:xfrm>
             <a:off x="2816352" y="4361688"/>
-            <a:ext cx="932688" cy="512064"/>
+            <a:ext cx="877824" cy="512064"/>
           </a:xfrm>
           <a:prstGeom prst="roundRect">
             <a:avLst/>
@@ -27508,7 +27508,7 @@
         <p:spPr>
           <a:xfrm>
             <a:off x="2862072" y="4535424"/>
-            <a:ext cx="841248" cy="118872"/>
+            <a:ext cx="786384" cy="118872"/>
           </a:xfrm>
           <a:prstGeom prst="rect">
             <a:avLst/>
@@ -27546,8 +27546,8 @@
         </p:nvSpPr>
         <p:spPr>
           <a:xfrm>
-            <a:off x="3840480" y="4361688"/>
-            <a:ext cx="932688" cy="512064"/>
+            <a:off x="3794760" y="4361688"/>
+            <a:ext cx="877824" cy="512064"/>
           </a:xfrm>
           <a:prstGeom prst="roundRect">
             <a:avLst/>
@@ -27591,8 +27591,8 @@
         </p:nvSpPr>
         <p:spPr>
           <a:xfrm>
-            <a:off x="3886200" y="4535424"/>
-            <a:ext cx="841248" cy="118872"/>
+            <a:off x="3840480" y="4535424"/>
+            <a:ext cx="786384" cy="118872"/>
           </a:xfrm>
           <a:prstGeom prst="rect">
             <a:avLst/>
@@ -27630,8 +27630,8 @@
         </p:nvSpPr>
         <p:spPr>
           <a:xfrm>
-            <a:off x="4864608" y="4361688"/>
-            <a:ext cx="932688" cy="512064"/>
+            <a:off x="4773168" y="4361688"/>
+            <a:ext cx="877824" cy="512064"/>
           </a:xfrm>
           <a:prstGeom prst="roundRect">
             <a:avLst/>
@@ -27675,8 +27675,8 @@
         </p:nvSpPr>
         <p:spPr>
           <a:xfrm>
-            <a:off x="4910328" y="4535424"/>
-            <a:ext cx="841248" cy="118872"/>
+            <a:off x="4818888" y="4535424"/>
+            <a:ext cx="786384" cy="118872"/>
           </a:xfrm>
           <a:prstGeom prst="rect">
             <a:avLst/>
@@ -27714,8 +27714,8 @@
         </p:nvSpPr>
         <p:spPr>
           <a:xfrm>
-            <a:off x="5888736" y="4361688"/>
-            <a:ext cx="932688" cy="512064"/>
+            <a:off x="5751576" y="4361688"/>
+            <a:ext cx="877824" cy="512064"/>
           </a:xfrm>
           <a:prstGeom prst="roundRect">
             <a:avLst/>
@@ -27759,8 +27759,8 @@
         </p:nvSpPr>
         <p:spPr>
           <a:xfrm>
-            <a:off x="5934456" y="4535424"/>
-            <a:ext cx="841248" cy="118872"/>
+            <a:off x="5797296" y="4535424"/>
+            <a:ext cx="786384" cy="118872"/>
           </a:xfrm>
           <a:prstGeom prst="rect">
             <a:avLst/>
@@ -27798,8 +27798,8 @@
         </p:nvSpPr>
         <p:spPr>
           <a:xfrm>
-            <a:off x="6912864" y="4361688"/>
-            <a:ext cx="932688" cy="512064"/>
+            <a:off x="6729984" y="4361688"/>
+            <a:ext cx="877824" cy="512064"/>
           </a:xfrm>
           <a:prstGeom prst="roundRect">
             <a:avLst/>
@@ -27843,8 +27843,8 @@
         </p:nvSpPr>
         <p:spPr>
           <a:xfrm>
-            <a:off x="6958584" y="4535424"/>
-            <a:ext cx="841248" cy="118872"/>
+            <a:off x="6775704" y="4535424"/>
+            <a:ext cx="786384" cy="118872"/>
           </a:xfrm>
           <a:prstGeom prst="rect">
             <a:avLst/>
@@ -27882,8 +27882,8 @@
         </p:nvSpPr>
         <p:spPr>
           <a:xfrm>
-            <a:off x="7936992" y="4361688"/>
-            <a:ext cx="932688" cy="512064"/>
+            <a:off x="7708392" y="4361688"/>
+            <a:ext cx="877824" cy="512064"/>
           </a:xfrm>
           <a:prstGeom prst="roundRect">
             <a:avLst/>
@@ -27927,8 +27927,8 @@
         </p:nvSpPr>
         <p:spPr>
           <a:xfrm>
-            <a:off x="7982712" y="4535424"/>
-            <a:ext cx="841248" cy="118872"/>
+            <a:off x="7754112" y="4535424"/>
+            <a:ext cx="786384" cy="118872"/>
           </a:xfrm>
           <a:prstGeom prst="rect">
             <a:avLst/>
@@ -27966,8 +27966,8 @@
         </p:nvSpPr>
         <p:spPr>
           <a:xfrm>
-            <a:off x="8961120" y="4361688"/>
-            <a:ext cx="932688" cy="512064"/>
+            <a:off x="8686800" y="4361688"/>
+            <a:ext cx="877824" cy="512064"/>
           </a:xfrm>
           <a:prstGeom prst="roundRect">
             <a:avLst/>
@@ -28011,8 +28011,8 @@
         </p:nvSpPr>
         <p:spPr>
           <a:xfrm>
-            <a:off x="9006840" y="4535424"/>
-            <a:ext cx="841248" cy="118872"/>
+            <a:off x="8732520" y="4535424"/>
+            <a:ext cx="786384" cy="118872"/>
           </a:xfrm>
           <a:prstGeom prst="rect">
             <a:avLst/>
@@ -28050,8 +28050,8 @@
         </p:nvSpPr>
         <p:spPr>
           <a:xfrm>
-            <a:off x="9985248" y="4361688"/>
-            <a:ext cx="932688" cy="512064"/>
+            <a:off x="9665208" y="4361688"/>
+            <a:ext cx="877824" cy="512064"/>
           </a:xfrm>
           <a:prstGeom prst="roundRect">
             <a:avLst/>
@@ -28095,8 +28095,8 @@
         </p:nvSpPr>
         <p:spPr>
           <a:xfrm>
-            <a:off x="10030968" y="4535424"/>
-            <a:ext cx="841248" cy="118872"/>
+            <a:off x="9710928" y="4535424"/>
+            <a:ext cx="786384" cy="118872"/>
           </a:xfrm>
           <a:prstGeom prst="rect">
             <a:avLst/>
@@ -28209,7 +28209,7 @@
         <p:spPr>
           <a:xfrm>
             <a:off x="2816352" y="5157216"/>
-            <a:ext cx="1307592" cy="512064"/>
+            <a:ext cx="1188720" cy="512064"/>
           </a:xfrm>
           <a:prstGeom prst="roundRect">
             <a:avLst/>
@@ -28254,7 +28254,7 @@
         <p:spPr>
           <a:xfrm>
             <a:off x="2862072" y="5330951"/>
-            <a:ext cx="1216151" cy="118872"/>
+            <a:ext cx="1097280" cy="118872"/>
           </a:xfrm>
           <a:prstGeom prst="rect">
             <a:avLst/>
@@ -28273,7 +28273,7 @@
               </a:lnSpc>
             </a:pPr>
             <a:r>
-              <a:rPr sz="840" b="1" i="0">
+              <a:rPr sz="800" b="1" i="0">
                 <a:solidFill>
                   <a:srgbClr val="F1F5FF"/>
                 </a:solidFill>
@@ -28292,8 +28292,8 @@
         </p:nvSpPr>
         <p:spPr>
           <a:xfrm>
-            <a:off x="4279392" y="5157216"/>
-            <a:ext cx="1307592" cy="512064"/>
+            <a:off x="4142232" y="5157216"/>
+            <a:ext cx="1188720" cy="512064"/>
           </a:xfrm>
           <a:prstGeom prst="roundRect">
             <a:avLst/>
@@ -28337,8 +28337,8 @@
         </p:nvSpPr>
         <p:spPr>
           <a:xfrm>
-            <a:off x="4325112" y="5330951"/>
-            <a:ext cx="1216151" cy="118872"/>
+            <a:off x="4187952" y="5330951"/>
+            <a:ext cx="1097280" cy="118872"/>
           </a:xfrm>
           <a:prstGeom prst="rect">
             <a:avLst/>
@@ -28357,7 +28357,7 @@
               </a:lnSpc>
             </a:pPr>
             <a:r>
-              <a:rPr sz="840" b="1" i="0">
+              <a:rPr sz="800" b="1" i="0">
                 <a:solidFill>
                   <a:srgbClr val="F1F5FF"/>
                 </a:solidFill>
@@ -28376,8 +28376,8 @@
         </p:nvSpPr>
         <p:spPr>
           <a:xfrm>
-            <a:off x="5742432" y="5157216"/>
-            <a:ext cx="1307592" cy="512064"/>
+            <a:off x="5468112" y="5157216"/>
+            <a:ext cx="1188720" cy="512064"/>
           </a:xfrm>
           <a:prstGeom prst="roundRect">
             <a:avLst/>
@@ -28421,8 +28421,8 @@
         </p:nvSpPr>
         <p:spPr>
           <a:xfrm>
-            <a:off x="5788152" y="5330951"/>
-            <a:ext cx="1216151" cy="118872"/>
+            <a:off x="5513832" y="5330951"/>
+            <a:ext cx="1097280" cy="118872"/>
           </a:xfrm>
           <a:prstGeom prst="rect">
             <a:avLst/>
@@ -28441,7 +28441,7 @@
               </a:lnSpc>
             </a:pPr>
             <a:r>
-              <a:rPr sz="840" b="1" i="0">
+              <a:rPr sz="800" b="1" i="0">
                 <a:solidFill>
                   <a:srgbClr val="F1F5FF"/>
                 </a:solidFill>
@@ -28460,8 +28460,8 @@
         </p:nvSpPr>
         <p:spPr>
           <a:xfrm>
-            <a:off x="7205472" y="5157216"/>
-            <a:ext cx="1307592" cy="512064"/>
+            <a:off x="6793992" y="5157216"/>
+            <a:ext cx="1188720" cy="512064"/>
           </a:xfrm>
           <a:prstGeom prst="roundRect">
             <a:avLst/>
@@ -28505,8 +28505,8 @@
         </p:nvSpPr>
         <p:spPr>
           <a:xfrm>
-            <a:off x="7251192" y="5330951"/>
-            <a:ext cx="1216151" cy="118872"/>
+            <a:off x="6839712" y="5330951"/>
+            <a:ext cx="1097280" cy="118872"/>
           </a:xfrm>
           <a:prstGeom prst="rect">
             <a:avLst/>
@@ -28525,7 +28525,7 @@
               </a:lnSpc>
             </a:pPr>
             <a:r>
-              <a:rPr sz="840" b="1" i="0">
+              <a:rPr sz="800" b="1" i="0">
                 <a:solidFill>
                   <a:srgbClr val="F1F5FF"/>
                 </a:solidFill>
@@ -28544,8 +28544,8 @@
         </p:nvSpPr>
         <p:spPr>
           <a:xfrm>
-            <a:off x="8668512" y="5157216"/>
-            <a:ext cx="1307592" cy="512064"/>
+            <a:off x="8119871" y="5157216"/>
+            <a:ext cx="1188720" cy="512064"/>
           </a:xfrm>
           <a:prstGeom prst="roundRect">
             <a:avLst/>
@@ -28589,8 +28589,8 @@
         </p:nvSpPr>
         <p:spPr>
           <a:xfrm>
-            <a:off x="8714232" y="5330951"/>
-            <a:ext cx="1216151" cy="118872"/>
+            <a:off x="8165592" y="5330951"/>
+            <a:ext cx="1097280" cy="118872"/>
           </a:xfrm>
           <a:prstGeom prst="rect">
             <a:avLst/>
@@ -28609,7 +28609,7 @@
               </a:lnSpc>
             </a:pPr>
             <a:r>
-              <a:rPr sz="840" b="1" i="0">
+              <a:rPr sz="800" b="1" i="0">
                 <a:solidFill>
                   <a:srgbClr val="F1F5FF"/>
                 </a:solidFill>
@@ -28628,8 +28628,8 @@
         </p:nvSpPr>
         <p:spPr>
           <a:xfrm>
-            <a:off x="7708392" y="5157216"/>
-            <a:ext cx="877824" cy="512064"/>
+            <a:off x="9445752" y="5157216"/>
+            <a:ext cx="1188720" cy="512064"/>
           </a:xfrm>
           <a:prstGeom prst="roundRect">
             <a:avLst/>
@@ -28673,8 +28673,8 @@
         </p:nvSpPr>
         <p:spPr>
           <a:xfrm>
-            <a:off x="7754112" y="5330951"/>
-            <a:ext cx="786384" cy="118872"/>
+            <a:off x="9491472" y="5330951"/>
+            <a:ext cx="1097280" cy="118872"/>
           </a:xfrm>
           <a:prstGeom prst="rect">
             <a:avLst/>
@@ -28693,7 +28693,7 @@
               </a:lnSpc>
             </a:pPr>
             <a:r>
-              <a:rPr sz="840" b="1" i="0">
+              <a:rPr sz="800" b="1" i="0">
                 <a:solidFill>
                   <a:srgbClr val="F1F5FF"/>
                 </a:solidFill>

</xml_diff>

<commit_message>
refactor: consolidate panels/screens, add agent center, update AI service
- Delete deprecated panels (Feed, Memory, Notifications, Overview) and
  screens (Projects, EngineeringOverview, GraphCanvas)
- Add AgentCenter, MemoryCenter, ToolsRail, FloatingPanel, and
  associated panels (Agent, AiChat, Dashboard, Governance, Twin, etc.)
- Add agent/learning/memory engines and stores for autonomous engineering
- Add automation and predictive packages, Cerebras provider adapter
- Restructure Home screen, ScreenRouter, and PanelWorkspace
- Update mission flow, diagnosis flow, and command bar
- Refactor AI service server, pipeline, and provider adapters
- Strip dead code from core, engineering-memory, and intelligence packages
- Add architecture docs (automation, predictive, provider integration)
- Regenerate knowledge graph
- Add verification scripts for providers, automation, predictive runtime
</commit_message>
<xml_diff>
--- a/presentation.pptx
+++ b/presentation.pptx
@@ -15898,7 +15898,7 @@
         <p:spPr>
           <a:xfrm>
             <a:off x="713232" y="694944"/>
-            <a:ext cx="9784080" cy="502920"/>
+            <a:ext cx="9784080" cy="713232"/>
           </a:xfrm>
           <a:prstGeom prst="rect">
             <a:avLst/>
@@ -15917,7 +15917,7 @@
               </a:lnSpc>
             </a:pPr>
             <a:r>
-              <a:rPr sz="2700" b="1" i="0">
+              <a:rPr sz="2550" b="1" i="0">
                 <a:solidFill>
                   <a:srgbClr val="F1F5FF"/>
                 </a:solidFill>
@@ -15936,8 +15936,8 @@
         </p:nvSpPr>
         <p:spPr>
           <a:xfrm>
-            <a:off x="731520" y="1243584"/>
-            <a:ext cx="9966960" cy="329184"/>
+            <a:off x="731520" y="1554480"/>
+            <a:ext cx="9966960" cy="201168"/>
           </a:xfrm>
           <a:prstGeom prst="rect">
             <a:avLst/>
@@ -15956,7 +15956,7 @@
               </a:lnSpc>
             </a:pPr>
             <a:r>
-              <a:rPr sz="1150" b="0" i="0">
+              <a:rPr sz="1120" b="0" i="0">
                 <a:solidFill>
                   <a:srgbClr val="91A0BA"/>
                 </a:solidFill>
@@ -16040,7 +16040,7 @@
             <a:r>
               <a:rPr sz="850" b="1" i="0">
                 <a:solidFill>
-                  <a:srgbClr val="47DCA2"/>
+                  <a:srgbClr val="080C14"/>
                 </a:solidFill>
                 <a:latin typeface="Aptos"/>
               </a:rPr>
@@ -18623,7 +18623,7 @@
         <p:spPr>
           <a:xfrm>
             <a:off x="713232" y="694944"/>
-            <a:ext cx="9784080" cy="502920"/>
+            <a:ext cx="9784080" cy="713232"/>
           </a:xfrm>
           <a:prstGeom prst="rect">
             <a:avLst/>
@@ -18642,7 +18642,7 @@
               </a:lnSpc>
             </a:pPr>
             <a:r>
-              <a:rPr sz="2700" b="1" i="0">
+              <a:rPr sz="2550" b="1" i="0">
                 <a:solidFill>
                   <a:srgbClr val="F1F5FF"/>
                 </a:solidFill>
@@ -18661,8 +18661,8 @@
         </p:nvSpPr>
         <p:spPr>
           <a:xfrm>
-            <a:off x="731520" y="1243584"/>
-            <a:ext cx="9966960" cy="329184"/>
+            <a:off x="731520" y="1554480"/>
+            <a:ext cx="9966960" cy="201168"/>
           </a:xfrm>
           <a:prstGeom prst="rect">
             <a:avLst/>
@@ -18681,7 +18681,7 @@
               </a:lnSpc>
             </a:pPr>
             <a:r>
-              <a:rPr sz="1150" b="0" i="0">
+              <a:rPr sz="1120" b="0" i="0">
                 <a:solidFill>
                   <a:srgbClr val="91A0BA"/>
                 </a:solidFill>
@@ -18765,7 +18765,7 @@
             <a:r>
               <a:rPr sz="850" b="1" i="0">
                 <a:solidFill>
-                  <a:srgbClr val="47DCA2"/>
+                  <a:srgbClr val="080C14"/>
                 </a:solidFill>
                 <a:latin typeface="Aptos"/>
               </a:rPr>
@@ -21318,7 +21318,7 @@
         <p:spPr>
           <a:xfrm>
             <a:off x="713232" y="694944"/>
-            <a:ext cx="9784080" cy="502920"/>
+            <a:ext cx="9784080" cy="713232"/>
           </a:xfrm>
           <a:prstGeom prst="rect">
             <a:avLst/>
@@ -21337,7 +21337,7 @@
               </a:lnSpc>
             </a:pPr>
             <a:r>
-              <a:rPr sz="2700" b="1" i="0">
+              <a:rPr sz="2550" b="1" i="0">
                 <a:solidFill>
                   <a:srgbClr val="F1F5FF"/>
                 </a:solidFill>
@@ -21356,8 +21356,8 @@
         </p:nvSpPr>
         <p:spPr>
           <a:xfrm>
-            <a:off x="731520" y="1243584"/>
-            <a:ext cx="9966960" cy="329184"/>
+            <a:off x="731520" y="1554480"/>
+            <a:ext cx="9966960" cy="201168"/>
           </a:xfrm>
           <a:prstGeom prst="rect">
             <a:avLst/>
@@ -21376,7 +21376,7 @@
               </a:lnSpc>
             </a:pPr>
             <a:r>
-              <a:rPr sz="1150" b="0" i="0">
+              <a:rPr sz="1120" b="0" i="0">
                 <a:solidFill>
                   <a:srgbClr val="91A0BA"/>
                 </a:solidFill>
@@ -21460,7 +21460,7 @@
             <a:r>
               <a:rPr sz="850" b="1" i="0">
                 <a:solidFill>
-                  <a:srgbClr val="47DCA2"/>
+                  <a:srgbClr val="080C14"/>
                 </a:solidFill>
                 <a:latin typeface="Aptos"/>
               </a:rPr>
@@ -23479,7 +23479,7 @@
         <p:spPr>
           <a:xfrm>
             <a:off x="713232" y="694944"/>
-            <a:ext cx="9784080" cy="502920"/>
+            <a:ext cx="9784080" cy="713232"/>
           </a:xfrm>
           <a:prstGeom prst="rect">
             <a:avLst/>
@@ -23498,7 +23498,7 @@
               </a:lnSpc>
             </a:pPr>
             <a:r>
-              <a:rPr sz="2700" b="1" i="0">
+              <a:rPr sz="2550" b="1" i="0">
                 <a:solidFill>
                   <a:srgbClr val="F1F5FF"/>
                 </a:solidFill>
@@ -23517,8 +23517,8 @@
         </p:nvSpPr>
         <p:spPr>
           <a:xfrm>
-            <a:off x="731520" y="1243584"/>
-            <a:ext cx="9966960" cy="329184"/>
+            <a:off x="731520" y="1554480"/>
+            <a:ext cx="9966960" cy="201168"/>
           </a:xfrm>
           <a:prstGeom prst="rect">
             <a:avLst/>
@@ -23537,7 +23537,7 @@
               </a:lnSpc>
             </a:pPr>
             <a:r>
-              <a:rPr sz="1150" b="0" i="0">
+              <a:rPr sz="1120" b="0" i="0">
                 <a:solidFill>
                   <a:srgbClr val="91A0BA"/>
                 </a:solidFill>
@@ -23621,7 +23621,7 @@
             <a:r>
               <a:rPr sz="850" b="1" i="0">
                 <a:solidFill>
-                  <a:srgbClr val="47DCA2"/>
+                  <a:srgbClr val="080C14"/>
                 </a:solidFill>
                 <a:latin typeface="Aptos"/>
               </a:rPr>
@@ -23846,7 +23846,7 @@
             <a:avLst/>
           </a:prstGeom>
           <a:solidFill>
-            <a:srgbClr val="47DCA2"/>
+            <a:srgbClr val="080C14"/>
           </a:solidFill>
           <a:ln>
             <a:noFill/>
@@ -23904,7 +23904,7 @@
             <a:r>
               <a:rPr sz="850" b="1" i="0">
                 <a:solidFill>
-                  <a:srgbClr val="47DCA2"/>
+                  <a:srgbClr val="080C14"/>
                 </a:solidFill>
                 <a:latin typeface="Aptos"/>
               </a:rPr>
@@ -24094,7 +24094,7 @@
             <a:avLst/>
           </a:prstGeom>
           <a:solidFill>
-            <a:srgbClr val="47DCA2"/>
+            <a:srgbClr val="080C14"/>
           </a:solidFill>
           <a:ln>
             <a:noFill/>
@@ -24152,7 +24152,7 @@
             <a:r>
               <a:rPr sz="850" b="1" i="0">
                 <a:solidFill>
-                  <a:srgbClr val="47DCA2"/>
+                  <a:srgbClr val="080C14"/>
                 </a:solidFill>
                 <a:latin typeface="Aptos"/>
               </a:rPr>
@@ -24342,7 +24342,7 @@
             <a:avLst/>
           </a:prstGeom>
           <a:solidFill>
-            <a:srgbClr val="5E83FF"/>
+            <a:srgbClr val="080C14"/>
           </a:solidFill>
           <a:ln>
             <a:noFill/>
@@ -24400,7 +24400,7 @@
             <a:r>
               <a:rPr sz="850" b="1" i="0">
                 <a:solidFill>
-                  <a:srgbClr val="5E83FF"/>
+                  <a:srgbClr val="080C14"/>
                 </a:solidFill>
                 <a:latin typeface="Aptos"/>
               </a:rPr>
@@ -24590,7 +24590,7 @@
             <a:avLst/>
           </a:prstGeom>
           <a:solidFill>
-            <a:srgbClr val="AE8BFF"/>
+            <a:srgbClr val="080C14"/>
           </a:solidFill>
           <a:ln>
             <a:noFill/>
@@ -24648,7 +24648,7 @@
             <a:r>
               <a:rPr sz="850" b="1" i="0">
                 <a:solidFill>
-                  <a:srgbClr val="AE8BFF"/>
+                  <a:srgbClr val="080C14"/>
                 </a:solidFill>
                 <a:latin typeface="Aptos"/>
               </a:rPr>
@@ -24838,7 +24838,7 @@
             <a:avLst/>
           </a:prstGeom>
           <a:solidFill>
-            <a:srgbClr val="4BD8F7"/>
+            <a:srgbClr val="080C14"/>
           </a:solidFill>
           <a:ln>
             <a:noFill/>
@@ -24896,7 +24896,7 @@
             <a:r>
               <a:rPr sz="850" b="1" i="0">
                 <a:solidFill>
-                  <a:srgbClr val="4BD8F7"/>
+                  <a:srgbClr val="080C14"/>
                 </a:solidFill>
                 <a:latin typeface="Aptos"/>
               </a:rPr>
@@ -25086,7 +25086,7 @@
             <a:avLst/>
           </a:prstGeom>
           <a:solidFill>
-            <a:srgbClr val="FFBF5B"/>
+            <a:srgbClr val="080C14"/>
           </a:solidFill>
           <a:ln>
             <a:noFill/>
@@ -25144,7 +25144,7 @@
             <a:r>
               <a:rPr sz="850" b="1" i="0">
                 <a:solidFill>
-                  <a:srgbClr val="FFBF5B"/>
+                  <a:srgbClr val="080C14"/>
                 </a:solidFill>
                 <a:latin typeface="Aptos"/>
               </a:rPr>
@@ -25634,7 +25634,7 @@
         <p:spPr>
           <a:xfrm>
             <a:off x="713232" y="694944"/>
-            <a:ext cx="9784080" cy="502920"/>
+            <a:ext cx="9784080" cy="713232"/>
           </a:xfrm>
           <a:prstGeom prst="rect">
             <a:avLst/>
@@ -25653,7 +25653,7 @@
               </a:lnSpc>
             </a:pPr>
             <a:r>
-              <a:rPr sz="2700" b="1" i="0">
+              <a:rPr sz="2550" b="1" i="0">
                 <a:solidFill>
                   <a:srgbClr val="F1F5FF"/>
                 </a:solidFill>
@@ -25672,8 +25672,8 @@
         </p:nvSpPr>
         <p:spPr>
           <a:xfrm>
-            <a:off x="731520" y="1243584"/>
-            <a:ext cx="9966960" cy="329184"/>
+            <a:off x="731520" y="1554480"/>
+            <a:ext cx="9966960" cy="201168"/>
           </a:xfrm>
           <a:prstGeom prst="rect">
             <a:avLst/>
@@ -25692,7 +25692,7 @@
               </a:lnSpc>
             </a:pPr>
             <a:r>
-              <a:rPr sz="1150" b="0" i="0">
+              <a:rPr sz="1120" b="0" i="0">
                 <a:solidFill>
                   <a:srgbClr val="91A0BA"/>
                 </a:solidFill>
@@ -25776,7 +25776,7 @@
             <a:r>
               <a:rPr sz="850" b="1" i="0">
                 <a:solidFill>
-                  <a:srgbClr val="47DCA2"/>
+                  <a:srgbClr val="080C14"/>
                 </a:solidFill>
                 <a:latin typeface="Aptos"/>
               </a:rPr>
@@ -29107,7 +29107,7 @@
         <p:spPr>
           <a:xfrm>
             <a:off x="713232" y="694944"/>
-            <a:ext cx="9784080" cy="502920"/>
+            <a:ext cx="9784080" cy="713232"/>
           </a:xfrm>
           <a:prstGeom prst="rect">
             <a:avLst/>
@@ -29126,7 +29126,7 @@
               </a:lnSpc>
             </a:pPr>
             <a:r>
-              <a:rPr sz="2700" b="1" i="0">
+              <a:rPr sz="2550" b="1" i="0">
                 <a:solidFill>
                   <a:srgbClr val="F1F5FF"/>
                 </a:solidFill>
@@ -29145,8 +29145,8 @@
         </p:nvSpPr>
         <p:spPr>
           <a:xfrm>
-            <a:off x="731520" y="1243584"/>
-            <a:ext cx="9966960" cy="329184"/>
+            <a:off x="731520" y="1554480"/>
+            <a:ext cx="9966960" cy="201168"/>
           </a:xfrm>
           <a:prstGeom prst="rect">
             <a:avLst/>
@@ -29165,7 +29165,7 @@
               </a:lnSpc>
             </a:pPr>
             <a:r>
-              <a:rPr sz="1150" b="0" i="0">
+              <a:rPr sz="1120" b="0" i="0">
                 <a:solidFill>
                   <a:srgbClr val="91A0BA"/>
                 </a:solidFill>
@@ -29249,7 +29249,7 @@
             <a:r>
               <a:rPr sz="850" b="1" i="0">
                 <a:solidFill>
-                  <a:srgbClr val="47DCA2"/>
+                  <a:srgbClr val="080C14"/>
                 </a:solidFill>
                 <a:latin typeface="Aptos"/>
               </a:rPr>
@@ -45853,7 +45853,7 @@
         <p:spPr>
           <a:xfrm>
             <a:off x="713232" y="694944"/>
-            <a:ext cx="9784080" cy="502920"/>
+            <a:ext cx="9784080" cy="713232"/>
           </a:xfrm>
           <a:prstGeom prst="rect">
             <a:avLst/>
@@ -45872,7 +45872,7 @@
               </a:lnSpc>
             </a:pPr>
             <a:r>
-              <a:rPr sz="2700" b="1" i="0">
+              <a:rPr sz="2550" b="1" i="0">
                 <a:solidFill>
                   <a:srgbClr val="F1F5FF"/>
                 </a:solidFill>
@@ -45891,8 +45891,8 @@
         </p:nvSpPr>
         <p:spPr>
           <a:xfrm>
-            <a:off x="731520" y="1243584"/>
-            <a:ext cx="9966960" cy="329184"/>
+            <a:off x="731520" y="1554480"/>
+            <a:ext cx="9966960" cy="201168"/>
           </a:xfrm>
           <a:prstGeom prst="rect">
             <a:avLst/>
@@ -45911,7 +45911,7 @@
               </a:lnSpc>
             </a:pPr>
             <a:r>
-              <a:rPr sz="1150" b="0" i="0">
+              <a:rPr sz="1120" b="0" i="0">
                 <a:solidFill>
                   <a:srgbClr val="91A0BA"/>
                 </a:solidFill>
@@ -47329,7 +47329,7 @@
         <p:spPr>
           <a:xfrm>
             <a:off x="713232" y="694944"/>
-            <a:ext cx="9784080" cy="502920"/>
+            <a:ext cx="9784080" cy="713232"/>
           </a:xfrm>
           <a:prstGeom prst="rect">
             <a:avLst/>
@@ -47348,7 +47348,7 @@
               </a:lnSpc>
             </a:pPr>
             <a:r>
-              <a:rPr sz="2700" b="1" i="0">
+              <a:rPr sz="2550" b="1" i="0">
                 <a:solidFill>
                   <a:srgbClr val="F1F5FF"/>
                 </a:solidFill>
@@ -47367,8 +47367,8 @@
         </p:nvSpPr>
         <p:spPr>
           <a:xfrm>
-            <a:off x="731520" y="1243584"/>
-            <a:ext cx="9966960" cy="329184"/>
+            <a:off x="731520" y="1554480"/>
+            <a:ext cx="9966960" cy="201168"/>
           </a:xfrm>
           <a:prstGeom prst="rect">
             <a:avLst/>
@@ -47387,7 +47387,7 @@
               </a:lnSpc>
             </a:pPr>
             <a:r>
-              <a:rPr sz="1150" b="0" i="0">
+              <a:rPr sz="1120" b="0" i="0">
                 <a:solidFill>
                   <a:srgbClr val="91A0BA"/>
                 </a:solidFill>
@@ -47471,7 +47471,7 @@
             <a:r>
               <a:rPr sz="850" b="1" i="0">
                 <a:solidFill>
-                  <a:srgbClr val="47DCA2"/>
+                  <a:srgbClr val="080C14"/>
                 </a:solidFill>
                 <a:latin typeface="Aptos"/>
               </a:rPr>
@@ -49184,7 +49184,7 @@
         <p:spPr>
           <a:xfrm>
             <a:off x="713232" y="694944"/>
-            <a:ext cx="9784080" cy="502920"/>
+            <a:ext cx="9784080" cy="713232"/>
           </a:xfrm>
           <a:prstGeom prst="rect">
             <a:avLst/>
@@ -49203,7 +49203,7 @@
               </a:lnSpc>
             </a:pPr>
             <a:r>
-              <a:rPr sz="2700" b="1" i="0">
+              <a:rPr sz="2550" b="1" i="0">
                 <a:solidFill>
                   <a:srgbClr val="F1F5FF"/>
                 </a:solidFill>
@@ -49222,8 +49222,8 @@
         </p:nvSpPr>
         <p:spPr>
           <a:xfrm>
-            <a:off x="731520" y="1243584"/>
-            <a:ext cx="9966960" cy="329184"/>
+            <a:off x="731520" y="1554480"/>
+            <a:ext cx="9966960" cy="201168"/>
           </a:xfrm>
           <a:prstGeom prst="rect">
             <a:avLst/>
@@ -49242,7 +49242,7 @@
               </a:lnSpc>
             </a:pPr>
             <a:r>
-              <a:rPr sz="1150" b="0" i="0">
+              <a:rPr sz="1120" b="0" i="0">
                 <a:solidFill>
                   <a:srgbClr val="91A0BA"/>
                 </a:solidFill>
@@ -49326,7 +49326,7 @@
             <a:r>
               <a:rPr sz="850" b="1" i="0">
                 <a:solidFill>
-                  <a:srgbClr val="47DCA2"/>
+                  <a:srgbClr val="080C14"/>
                 </a:solidFill>
                 <a:latin typeface="Aptos"/>
               </a:rPr>
@@ -52641,7 +52641,7 @@
         <p:spPr>
           <a:xfrm>
             <a:off x="713232" y="694944"/>
-            <a:ext cx="9784080" cy="502920"/>
+            <a:ext cx="9784080" cy="713232"/>
           </a:xfrm>
           <a:prstGeom prst="rect">
             <a:avLst/>
@@ -52660,7 +52660,7 @@
               </a:lnSpc>
             </a:pPr>
             <a:r>
-              <a:rPr sz="2700" b="1" i="0">
+              <a:rPr sz="2550" b="1" i="0">
                 <a:solidFill>
                   <a:srgbClr val="F1F5FF"/>
                 </a:solidFill>
@@ -52679,8 +52679,8 @@
         </p:nvSpPr>
         <p:spPr>
           <a:xfrm>
-            <a:off x="731520" y="1243584"/>
-            <a:ext cx="9966960" cy="329184"/>
+            <a:off x="731520" y="1554480"/>
+            <a:ext cx="9966960" cy="201168"/>
           </a:xfrm>
           <a:prstGeom prst="rect">
             <a:avLst/>
@@ -52699,7 +52699,7 @@
               </a:lnSpc>
             </a:pPr>
             <a:r>
-              <a:rPr sz="1150" b="0" i="0">
+              <a:rPr sz="1120" b="0" i="0">
                 <a:solidFill>
                   <a:srgbClr val="91A0BA"/>
                 </a:solidFill>
@@ -52783,7 +52783,7 @@
             <a:r>
               <a:rPr sz="850" b="1" i="0">
                 <a:solidFill>
-                  <a:srgbClr val="47DCA2"/>
+                  <a:srgbClr val="080C14"/>
                 </a:solidFill>
                 <a:latin typeface="Aptos"/>
               </a:rPr>
@@ -55108,7 +55108,7 @@
             <a:avLst/>
           </a:prstGeom>
           <a:solidFill>
-            <a:srgbClr val="47DCA2"/>
+            <a:srgbClr val="080C14"/>
           </a:solidFill>
           <a:ln>
             <a:noFill/>
@@ -55166,7 +55166,7 @@
             <a:r>
               <a:rPr sz="850" b="1" i="0">
                 <a:solidFill>
-                  <a:srgbClr val="47DCA2"/>
+                  <a:srgbClr val="080C14"/>
                 </a:solidFill>
                 <a:latin typeface="Aptos"/>
               </a:rPr>
@@ -55233,7 +55233,7 @@
             <a:avLst/>
           </a:prstGeom>
           <a:solidFill>
-            <a:srgbClr val="FFBF5B"/>
+            <a:srgbClr val="080C14"/>
           </a:solidFill>
           <a:ln>
             <a:noFill/>
@@ -55291,7 +55291,7 @@
             <a:r>
               <a:rPr sz="850" b="1" i="0">
                 <a:solidFill>
-                  <a:srgbClr val="FFBF5B"/>
+                  <a:srgbClr val="080C14"/>
                 </a:solidFill>
                 <a:latin typeface="Aptos"/>
               </a:rPr>
@@ -55658,7 +55658,7 @@
         <p:spPr>
           <a:xfrm>
             <a:off x="713232" y="694944"/>
-            <a:ext cx="9784080" cy="502920"/>
+            <a:ext cx="9784080" cy="713232"/>
           </a:xfrm>
           <a:prstGeom prst="rect">
             <a:avLst/>
@@ -55677,7 +55677,7 @@
               </a:lnSpc>
             </a:pPr>
             <a:r>
-              <a:rPr sz="2700" b="1" i="0">
+              <a:rPr sz="2550" b="1" i="0">
                 <a:solidFill>
                   <a:srgbClr val="F1F5FF"/>
                 </a:solidFill>
@@ -55696,8 +55696,8 @@
         </p:nvSpPr>
         <p:spPr>
           <a:xfrm>
-            <a:off x="731520" y="1243584"/>
-            <a:ext cx="9966960" cy="329184"/>
+            <a:off x="731520" y="1554480"/>
+            <a:ext cx="9966960" cy="201168"/>
           </a:xfrm>
           <a:prstGeom prst="rect">
             <a:avLst/>
@@ -55716,7 +55716,7 @@
               </a:lnSpc>
             </a:pPr>
             <a:r>
-              <a:rPr sz="1150" b="0" i="0">
+              <a:rPr sz="1120" b="0" i="0">
                 <a:solidFill>
                   <a:srgbClr val="91A0BA"/>
                 </a:solidFill>
@@ -55800,7 +55800,7 @@
             <a:r>
               <a:rPr sz="850" b="1" i="0">
                 <a:solidFill>
-                  <a:srgbClr val="47DCA2"/>
+                  <a:srgbClr val="080C14"/>
                 </a:solidFill>
                 <a:latin typeface="Aptos"/>
               </a:rPr>
@@ -58177,7 +58177,7 @@
         <p:spPr>
           <a:xfrm>
             <a:off x="713232" y="694944"/>
-            <a:ext cx="9784080" cy="502920"/>
+            <a:ext cx="9784080" cy="713232"/>
           </a:xfrm>
           <a:prstGeom prst="rect">
             <a:avLst/>
@@ -58196,7 +58196,7 @@
               </a:lnSpc>
             </a:pPr>
             <a:r>
-              <a:rPr sz="2700" b="1" i="0">
+              <a:rPr sz="2550" b="1" i="0">
                 <a:solidFill>
                   <a:srgbClr val="F1F5FF"/>
                 </a:solidFill>
@@ -58215,8 +58215,8 @@
         </p:nvSpPr>
         <p:spPr>
           <a:xfrm>
-            <a:off x="731520" y="1243584"/>
-            <a:ext cx="9966960" cy="329184"/>
+            <a:off x="731520" y="1554480"/>
+            <a:ext cx="9966960" cy="201168"/>
           </a:xfrm>
           <a:prstGeom prst="rect">
             <a:avLst/>
@@ -58235,7 +58235,7 @@
               </a:lnSpc>
             </a:pPr>
             <a:r>
-              <a:rPr sz="1150" b="0" i="0">
+              <a:rPr sz="1120" b="0" i="0">
                 <a:solidFill>
                   <a:srgbClr val="91A0BA"/>
                 </a:solidFill>
@@ -58319,7 +58319,7 @@
             <a:r>
               <a:rPr sz="850" b="1" i="0">
                 <a:solidFill>
-                  <a:srgbClr val="47DCA2"/>
+                  <a:srgbClr val="080C14"/>
                 </a:solidFill>
                 <a:latin typeface="Aptos"/>
               </a:rPr>
@@ -61686,7 +61686,7 @@
             <a:avLst/>
           </a:prstGeom>
           <a:solidFill>
-            <a:srgbClr val="47DCA2"/>
+            <a:srgbClr val="080C14"/>
           </a:solidFill>
           <a:ln>
             <a:noFill/>
@@ -61744,7 +61744,7 @@
             <a:r>
               <a:rPr sz="850" b="1" i="0">
                 <a:solidFill>
-                  <a:srgbClr val="47DCA2"/>
+                  <a:srgbClr val="080C14"/>
                 </a:solidFill>
                 <a:latin typeface="Aptos"/>
               </a:rPr>
@@ -62111,7 +62111,7 @@
         <p:spPr>
           <a:xfrm>
             <a:off x="713232" y="694944"/>
-            <a:ext cx="9784080" cy="502920"/>
+            <a:ext cx="9784080" cy="713232"/>
           </a:xfrm>
           <a:prstGeom prst="rect">
             <a:avLst/>
@@ -62130,7 +62130,7 @@
               </a:lnSpc>
             </a:pPr>
             <a:r>
-              <a:rPr sz="2700" b="1" i="0">
+              <a:rPr sz="2550" b="1" i="0">
                 <a:solidFill>
                   <a:srgbClr val="F1F5FF"/>
                 </a:solidFill>
@@ -62149,8 +62149,8 @@
         </p:nvSpPr>
         <p:spPr>
           <a:xfrm>
-            <a:off x="731520" y="1243584"/>
-            <a:ext cx="9966960" cy="329184"/>
+            <a:off x="731520" y="1554480"/>
+            <a:ext cx="9966960" cy="201168"/>
           </a:xfrm>
           <a:prstGeom prst="rect">
             <a:avLst/>
@@ -62169,7 +62169,7 @@
               </a:lnSpc>
             </a:pPr>
             <a:r>
-              <a:rPr sz="1150" b="0" i="0">
+              <a:rPr sz="1120" b="0" i="0">
                 <a:solidFill>
                   <a:srgbClr val="91A0BA"/>
                 </a:solidFill>
@@ -62253,7 +62253,7 @@
             <a:r>
               <a:rPr sz="850" b="1" i="0">
                 <a:solidFill>
-                  <a:srgbClr val="47DCA2"/>
+                  <a:srgbClr val="080C14"/>
                 </a:solidFill>
                 <a:latin typeface="Aptos"/>
               </a:rPr>
@@ -62614,7 +62614,7 @@
                 </a:solidFill>
                 <a:latin typeface="Aptos"/>
               </a:rPr>
-              <a:t>classification +</a:t>
+              <a:t>classify +</a:t>
             </a:r>
           </a:p>
           <a:p>
@@ -62630,7 +62630,7 @@
                 </a:solidFill>
                 <a:latin typeface="Aptos"/>
               </a:rPr>
-              <a:t>refinement</a:t>
+              <a:t>refine</a:t>
             </a:r>
           </a:p>
         </p:txBody>
@@ -62874,7 +62874,7 @@
                 </a:solidFill>
                 <a:latin typeface="Aptos"/>
               </a:rPr>
-              <a:t>SIGNALS</a:t>
+              <a:t>SIGNAL</a:t>
             </a:r>
           </a:p>
         </p:txBody>
@@ -62913,7 +62913,7 @@
                 </a:solidFill>
                 <a:latin typeface="Aptos"/>
               </a:rPr>
-              <a:t>health · hotspots</a:t>
+              <a:t>health +</a:t>
             </a:r>
           </a:p>
           <a:p>
@@ -62929,7 +62929,7 @@
                 </a:solidFill>
                 <a:latin typeface="Aptos"/>
               </a:rPr>
-              <a:t>changes · debt</a:t>
+              <a:t>debt</a:t>
             </a:r>
           </a:p>
         </p:txBody>
@@ -63173,7 +63173,7 @@
                 </a:solidFill>
                 <a:latin typeface="Aptos"/>
               </a:rPr>
-              <a:t>GOAL GRAPH</a:t>
+              <a:t>GOALS</a:t>
             </a:r>
           </a:p>
         </p:txBody>
@@ -63212,7 +63212,7 @@
                 </a:solidFill>
                 <a:latin typeface="Aptos"/>
               </a:rPr>
-              <a:t>goals · tasks</a:t>
+              <a:t>goals +</a:t>
             </a:r>
           </a:p>
           <a:p>
@@ -63228,7 +63228,7 @@
                 </a:solidFill>
                 <a:latin typeface="Aptos"/>
               </a:rPr>
-              <a:t>dependencies</a:t>
+              <a:t>deps</a:t>
             </a:r>
           </a:p>
         </p:txBody>
@@ -63511,7 +63511,7 @@
                 </a:solidFill>
                 <a:latin typeface="Aptos"/>
               </a:rPr>
-              <a:t>deterministic</a:t>
+              <a:t>risk</a:t>
             </a:r>
           </a:p>
           <a:p>
@@ -63527,7 +63527,7 @@
                 </a:solidFill>
                 <a:latin typeface="Aptos"/>
               </a:rPr>
-              <a:t>analysis</a:t>
+              <a:t>floor</a:t>
             </a:r>
           </a:p>
         </p:txBody>
@@ -63810,7 +63810,7 @@
                 </a:solidFill>
                 <a:latin typeface="Aptos"/>
               </a:rPr>
-              <a:t>adversarial</a:t>
+              <a:t>quality</a:t>
             </a:r>
           </a:p>
           <a:p>
@@ -63826,7 +63826,7 @@
                 </a:solidFill>
                 <a:latin typeface="Aptos"/>
               </a:rPr>
-              <a:t>quality score</a:t>
+              <a:t>score</a:t>
             </a:r>
           </a:p>
         </p:txBody>
@@ -65798,7 +65798,7 @@
         <p:spPr>
           <a:xfrm>
             <a:off x="713232" y="694944"/>
-            <a:ext cx="9784080" cy="502920"/>
+            <a:ext cx="9784080" cy="713232"/>
           </a:xfrm>
           <a:prstGeom prst="rect">
             <a:avLst/>
@@ -65817,7 +65817,7 @@
               </a:lnSpc>
             </a:pPr>
             <a:r>
-              <a:rPr sz="2700" b="1" i="0">
+              <a:rPr sz="2550" b="1" i="0">
                 <a:solidFill>
                   <a:srgbClr val="F1F5FF"/>
                 </a:solidFill>
@@ -65836,8 +65836,8 @@
         </p:nvSpPr>
         <p:spPr>
           <a:xfrm>
-            <a:off x="731520" y="1243584"/>
-            <a:ext cx="9966960" cy="329184"/>
+            <a:off x="731520" y="1554480"/>
+            <a:ext cx="9966960" cy="201168"/>
           </a:xfrm>
           <a:prstGeom prst="rect">
             <a:avLst/>
@@ -65856,7 +65856,7 @@
               </a:lnSpc>
             </a:pPr>
             <a:r>
-              <a:rPr sz="1150" b="0" i="0">
+              <a:rPr sz="1120" b="0" i="0">
                 <a:solidFill>
                   <a:srgbClr val="91A0BA"/>
                 </a:solidFill>
@@ -65940,7 +65940,7 @@
             <a:r>
               <a:rPr sz="850" b="1" i="0">
                 <a:solidFill>
-                  <a:srgbClr val="47DCA2"/>
+                  <a:srgbClr val="080C14"/>
                 </a:solidFill>
                 <a:latin typeface="Aptos"/>
               </a:rPr>

</xml_diff>